<commit_message>
Add three-route Figure 8 method comparison
Separate the seven-round benchmark, 2021-direct full-inverse
reconstruction, and public-FWTW robustness route. Add comparison
metrics, tests, documentation, and the focused presentation.

Validation: 36 tests passed; presentation QA passed.
AI-assisted implementation and documentation.
</commit_message>
<xml_diff>
--- a/Presentation/6_figure8_method_comparison/presentation.pptx
+++ b/Presentation/6_figure8_method_comparison/presentation.pptx
@@ -2,20 +2,20 @@
 <file path=ppt/presentation.xml><?xml version="1.0" encoding="utf-8"?>
 <p:presentation xmlns:p="http://schemas.openxmlformats.org/presentationml/2006/main">
   <p:sldMasterIdLst>
-    <p:sldMasterId xmlns:r="http://schemas.openxmlformats.org/officeDocument/2006/relationships" id="2147483648" r:id="R995de10982c440a8"/>
+    <p:sldMasterId xmlns:r="http://schemas.openxmlformats.org/officeDocument/2006/relationships" id="2147483648" r:id="R1b4164fdcfc04f14"/>
   </p:sldMasterIdLst>
   <p:notesMasterIdLst>
-    <p:notesMasterId xmlns:r="http://schemas.openxmlformats.org/officeDocument/2006/relationships" r:id="Rb0d92dbf1811462b"/>
+    <p:notesMasterId xmlns:r="http://schemas.openxmlformats.org/officeDocument/2006/relationships" r:id="R32674529eafb4d9f"/>
   </p:notesMasterIdLst>
   <p:sldIdLst>
-    <p:sldId xmlns:r="http://schemas.openxmlformats.org/officeDocument/2006/relationships" id="256" r:id="R5219d21714954a53"/>
-    <p:sldId xmlns:r="http://schemas.openxmlformats.org/officeDocument/2006/relationships" id="257" r:id="R82ffa5d5b3324850"/>
-    <p:sldId xmlns:r="http://schemas.openxmlformats.org/officeDocument/2006/relationships" id="258" r:id="Rd4f451282d6f4d8e"/>
-    <p:sldId xmlns:r="http://schemas.openxmlformats.org/officeDocument/2006/relationships" id="259" r:id="Rf80b7847ded44255"/>
-    <p:sldId xmlns:r="http://schemas.openxmlformats.org/officeDocument/2006/relationships" id="260" r:id="R5a864849d9b449f1"/>
-    <p:sldId xmlns:r="http://schemas.openxmlformats.org/officeDocument/2006/relationships" id="261" r:id="R36193fde03b3416a"/>
-    <p:sldId xmlns:r="http://schemas.openxmlformats.org/officeDocument/2006/relationships" id="262" r:id="Rf60a6db337274a9c"/>
-    <p:sldId xmlns:r="http://schemas.openxmlformats.org/officeDocument/2006/relationships" id="263" r:id="Rf005935ede11441a"/>
+    <p:sldId xmlns:r="http://schemas.openxmlformats.org/officeDocument/2006/relationships" id="256" r:id="R75c00d5e719b4a6e"/>
+    <p:sldId xmlns:r="http://schemas.openxmlformats.org/officeDocument/2006/relationships" id="257" r:id="Rd54b0e7aa5484aef"/>
+    <p:sldId xmlns:r="http://schemas.openxmlformats.org/officeDocument/2006/relationships" id="258" r:id="R5511eee0c4734e20"/>
+    <p:sldId xmlns:r="http://schemas.openxmlformats.org/officeDocument/2006/relationships" id="259" r:id="Rb9038c46540c43b7"/>
+    <p:sldId xmlns:r="http://schemas.openxmlformats.org/officeDocument/2006/relationships" id="260" r:id="R2841a861ea2b490d"/>
+    <p:sldId xmlns:r="http://schemas.openxmlformats.org/officeDocument/2006/relationships" id="261" r:id="Rc355bb02c577443b"/>
+    <p:sldId xmlns:r="http://schemas.openxmlformats.org/officeDocument/2006/relationships" id="262" r:id="R29ae884459c94cde"/>
+    <p:sldId xmlns:r="http://schemas.openxmlformats.org/officeDocument/2006/relationships" id="263" r:id="R7680a5b86b714aa9"/>
   </p:sldIdLst>
   <p:sldSz cx="12192000" cy="6858000"/>
   <p:notesSz cx="6858000" cy="9144000"/>
@@ -459,6 +459,11 @@
           </a:p>
           <a:p xmlns:a="http://schemas.openxmlformats.org/drawingml/2006/main">
             <a:r>
+              <a:t>- docs/data/figure8-2021-direct-data.md</a:t>
+            </a:r>
+          </a:p>
+          <a:p xmlns:a="http://schemas.openxmlformats.org/drawingml/2006/main">
+            <a:r>
               <a:t>- docs/data/figure8-public-fwtw-data.md</a:t>
             </a:r>
           </a:p>
@@ -544,12 +549,17 @@
           </a:p>
           <a:p xmlns:a="http://schemas.openxmlformats.org/drawingml/2006/main">
             <a:r>
+              <a:t>- Code/unveiling/figure8_authors.py</a:t>
+            </a:r>
+          </a:p>
+          <a:p xmlns:a="http://schemas.openxmlformats.org/drawingml/2006/main">
+            <a:r>
+              <a:t>- Code/unveiling/figure8_2021_direct.py</a:t>
+            </a:r>
+          </a:p>
+          <a:p xmlns:a="http://schemas.openxmlformats.org/drawingml/2006/main">
+            <a:r>
               <a:t>- Code/unveiling/figure8_public_fwtw.py</a:t>
-            </a:r>
-          </a:p>
-          <a:p xmlns:a="http://schemas.openxmlformats.org/drawingml/2006/main">
-            <a:r>
-              <a:t>- Code/unveiling/figure8_authors.py</a:t>
             </a:r>
           </a:p>
         </p:txBody>
@@ -629,17 +639,17 @@
           </a:p>
           <a:p xmlns:a="http://schemas.openxmlformats.org/drawingml/2006/main">
             <a:r>
-              <a:t>- Data/raw/fwtw/fwtw_data_2026-06-18.csv</a:t>
+              <a:t>- docs/data/figure8-data.md</a:t>
+            </a:r>
+          </a:p>
+          <a:p xmlns:a="http://schemas.openxmlformats.org/drawingml/2006/main">
+            <a:r>
+              <a:t>- docs/data/figure8-2021-direct-data.md</a:t>
             </a:r>
           </a:p>
           <a:p xmlns:a="http://schemas.openxmlformats.org/drawingml/2006/main">
             <a:r>
               <a:t>- docs/data/figure8-public-fwtw-data.md</a:t>
-            </a:r>
-          </a:p>
-          <a:p xmlns:a="http://schemas.openxmlformats.org/drawingml/2006/main">
-            <a:r>
-              <a:t>- docs/data/figure8-data.md</a:t>
             </a:r>
           </a:p>
         </p:txBody>
@@ -719,12 +729,17 @@
           </a:p>
           <a:p xmlns:a="http://schemas.openxmlformats.org/drawingml/2006/main">
             <a:r>
-              <a:t>- Code/unveiling/figure8_public_fwtw.py</a:t>
-            </a:r>
-          </a:p>
-          <a:p xmlns:a="http://schemas.openxmlformats.org/drawingml/2006/main">
-            <a:r>
-              <a:t>- Data/interim/figure8_public_fwtw_network_diagnostics.csv</a:t>
+              <a:t>- Code/unveiling/figure8_2021_direct.py</a:t>
+            </a:r>
+          </a:p>
+          <a:p xmlns:a="http://schemas.openxmlformats.org/drawingml/2006/main">
+            <a:r>
+              <a:t>- Data/interim/figure8_2021_direct_network_diagnostics.csv</a:t>
+            </a:r>
+          </a:p>
+          <a:p xmlns:a="http://schemas.openxmlformats.org/drawingml/2006/main">
+            <a:r>
+              <a:t>- Data/interim/figure8_2021_direct_component_diagnostics.csv</a:t>
             </a:r>
           </a:p>
         </p:txBody>
@@ -984,22 +999,22 @@
           </a:p>
           <a:p xmlns:a="http://schemas.openxmlformats.org/drawingml/2006/main">
             <a:r>
-              <a:t>- Results_Proposal/figures/figure8_public_fwtw_full_leontief.png</a:t>
-            </a:r>
-          </a:p>
-          <a:p xmlns:a="http://schemas.openxmlformats.org/drawingml/2006/main">
-            <a:r>
-              <a:t>- Results_Proposal/figures/figure8_public_fwtw_sensitivity.png</a:t>
-            </a:r>
-          </a:p>
-          <a:p xmlns:a="http://schemas.openxmlformats.org/drawingml/2006/main">
-            <a:r>
-              <a:t>- Data/interim/figure8_public_fwtw_network_diagnostics.csv</a:t>
-            </a:r>
-          </a:p>
-          <a:p xmlns:a="http://schemas.openxmlformats.org/drawingml/2006/main">
-            <a:r>
-              <a:t>- https://www.federalreserve.gov/releases/efa/fwtw.htm</a:t>
+              <a:t>- Results_Proposal/figures/figure8_2021_operator_comparison.png</a:t>
+            </a:r>
+          </a:p>
+          <a:p xmlns:a="http://schemas.openxmlformats.org/drawingml/2006/main">
+            <a:r>
+              <a:t>- Results_Proposal/figures/figure8_2021_direct_full_leontief.png</a:t>
+            </a:r>
+          </a:p>
+          <a:p xmlns:a="http://schemas.openxmlformats.org/drawingml/2006/main">
+            <a:r>
+              <a:t>- Data/processed/figure8_2021_operator_comparison_metrics.csv</a:t>
+            </a:r>
+          </a:p>
+          <a:p xmlns:a="http://schemas.openxmlformats.org/drawingml/2006/main">
+            <a:r>
+              <a:t>- Data/interim/figure8_2021_direct_network_diagnostics.csv</a:t>
             </a:r>
           </a:p>
         </p:txBody>
@@ -1075,6 +1090,11 @@
           <a:p xmlns:a="http://schemas.openxmlformats.org/drawingml/2006/main">
             <a:r>
               <a:t>- docs/project/tasks/figure8-replication.md</a:t>
+            </a:r>
+          </a:p>
+          <a:p xmlns:a="http://schemas.openxmlformats.org/drawingml/2006/main">
+            <a:r>
+              <a:t>- docs/data/figure8-2021-direct-data.md</a:t>
             </a:r>
           </a:p>
           <a:p xmlns:a="http://schemas.openxmlformats.org/drawingml/2006/main">
@@ -1157,7 +1177,7 @@
   </p:cSld>
   <p:clrMap bg1="lt1" tx1="dk1" bg2="lt2" tx2="dk2" accent1="accent1" accent2="accent2" accent3="accent3" accent4="accent4" accent5="accent5" accent6="accent6" hlink="hlink" folHlink="folHlink"/>
   <p:sldLayoutIdLst>
-    <p:sldLayoutId xmlns:r="http://schemas.openxmlformats.org/officeDocument/2006/relationships" id="2147483649" r:id="R991437bdbc1c42a5"/>
+    <p:sldLayoutId xmlns:r="http://schemas.openxmlformats.org/officeDocument/2006/relationships" id="2147483649" r:id="Re63d642f7ab4466d"/>
   </p:sldLayoutIdLst>
   <p:txStyles>
     <p:titleStyle>
@@ -1831,7 +1851,7 @@
                   <a:srgbClr val="102A43"/>
                 </a:solidFill>
               </a:rPr>
-              <a:t>Two routes to unveiled net household debt</a:t>
+              <a:t>Three routes to unveiled net household debt</a:t>
             </a:r>
           </a:p>
         </p:txBody>
@@ -1882,7 +1902,7 @@
                   <a:srgbClr val="243B53"/>
                 </a:solidFill>
               </a:rPr>
-              <a:t>Same 2025 estimand; different upstream data and network operators</a:t>
+              <a:t>Separate the data vintage from the network operator</a:t>
             </a:r>
           </a:p>
         </p:txBody>
@@ -1964,7 +1984,7 @@
                   <a:srgbClr val="243B53"/>
                 </a:solidFill>
               </a:rPr>
-              <a:t>Preferred: public FWTW + full Leontief reconstruction</a:t>
+              <a:t>Full inverse: B · 2021 direct cells   C · public FWTW</a:t>
             </a:r>
           </a:p>
         </p:txBody>
@@ -2046,7 +2066,7 @@
                   <a:srgbClr val="243B53"/>
                 </a:solidFill>
               </a:rPr>
-              <a:t>Retained: 2021-kit + seven-round proxy</a:t>
+              <a:t>Seven rounds: A · 2021 final-file benchmark</a:t>
             </a:r>
           </a:p>
         </p:txBody>
@@ -2097,7 +2117,7 @@
                   <a:srgbClr val="627D98"/>
                 </a:solidFill>
               </a:rPr>
-              <a:t>13 August 2026</a:t>
+              <a:t>14 August 2026</a:t>
             </a:r>
           </a:p>
         </p:txBody>
@@ -2228,7 +2248,7 @@
                   <a:srgbClr val="102A43"/>
                 </a:solidFill>
               </a:rPr>
-              <a:t>Both routes estimate the same net-debt object</a:t>
+              <a:t>One estimand, three deliberately separate routes</a:t>
             </a:r>
           </a:p>
         </p:txBody>
@@ -2543,7 +2563,7 @@
                   <a:srgbClr val="627D98"/>
                 </a:solidFill>
               </a:rPr>
-              <a:t>Paper target</a:t>
+              <a:t>A · Old benchmark</a:t>
             </a:r>
           </a:p>
         </p:txBody>
@@ -2594,7 +2614,7 @@
                   <a:srgbClr val="243B53"/>
                 </a:solidFill>
               </a:rPr>
-              <a:t>Augment the household owner by wealth group, fully unveil the network, then isolate household debt.</a:t>
+              <a:t>2021 final debt positions after the authors’ seven-round unveiling; revised display rule only.</a:t>
             </a:r>
           </a:p>
         </p:txBody>
@@ -2676,7 +2696,7 @@
                   <a:srgbClr val="2E5B88"/>
                 </a:solidFill>
               </a:rPr>
-              <a:t>Preferred route</a:t>
+              <a:t>B · Primary test</a:t>
             </a:r>
           </a:p>
         </p:txBody>
@@ -2727,7 +2747,7 @@
                   <a:srgbClr val="243B53"/>
                 </a:solidFill>
               </a:rPr>
-              <a:t>Published FWTW bilateral levels + 2021 DINA/NIPA + full Leontief inverse.</a:t>
+              <a:t>2021 direct/pre-unveiling cells, reconstructed network, and the 2025 full Leontief operator.</a:t>
             </a:r>
           </a:p>
         </p:txBody>
@@ -2809,7 +2829,7 @@
                   <a:srgbClr val="C65D16"/>
                 </a:solidFill>
               </a:rPr>
-              <a:t>Retained route</a:t>
+              <a:t>C · Public robustness</a:t>
             </a:r>
           </a:p>
         </p:txBody>
@@ -2860,7 +2880,7 @@
                   <a:srgbClr val="243B53"/>
                 </a:solidFill>
               </a:rPr>
-              <a:t>Authors’ final seven-round debt positions + the same group, sign, scale, and base rule.</a:t>
+              <a:t>Current public FWTW bilateral levels plus 2021 DINA/NIPA and the same full operator.</a:t>
             </a:r>
           </a:p>
         </p:txBody>
@@ -2944,7 +2964,7 @@
                   <a:srgbClr val="B83232"/>
                 </a:solidFill>
               </a:rPr>
-              <a:t>Naming rule</a:t>
+              <a:t>Why three?</a:t>
             </a:r>
           </a:p>
         </p:txBody>
@@ -2995,7 +3015,7 @@
                   <a:srgbClr val="243B53"/>
                 </a:solidFill>
               </a:rPr>
-              <a:t>Call the new result a public-FWTW full-Leontief reconstruction—not an exact reproduction of the unavailable authors’ 2025 vintage.</a:t>
+              <a:t>A→B changes the operator while holding the old vintage as close as saved inputs permit; C tests the method on an independent public network.</a:t>
             </a:r>
           </a:p>
         </p:txBody>
@@ -3075,7 +3095,7 @@
                   <a:srgbClr val="C65D16"/>
                 </a:solidFill>
               </a:rPr>
-              <a:t>TWO APPROACHES</a:t>
+              <a:t>METHOD CROSSWALK</a:t>
             </a:r>
           </a:p>
         </p:txBody>
@@ -3126,7 +3146,7 @@
                   <a:srgbClr val="102A43"/>
                 </a:solidFill>
               </a:rPr>
-              <a:t>Only the new route rebuilds the direct network</a:t>
+              <a:t>Data and operator choices are now visible separately</a:t>
             </a:r>
           </a:p>
         </p:txBody>
@@ -3545,7 +3565,7 @@
                   <a:srgbClr val="243B53"/>
                 </a:solidFill>
               </a:rPr>
-              <a:t>Custom 2019 vintage</a:t>
+              <a:t>Authors’ 2019 vintage</a:t>
             </a:r>
           </a:p>
         </p:txBody>
@@ -3729,7 +3749,7 @@
                   <a:srgbClr val="243B53"/>
                 </a:solidFill>
               </a:rPr>
-              <a:t>Old proxy</a:t>
+              <a:t>A · Old benchmark</a:t>
             </a:r>
           </a:p>
         </p:txBody>
@@ -3882,7 +3902,7 @@
                   <a:srgbClr val="243B53"/>
                 </a:solidFill>
               </a:rPr>
-              <a:t>Starts after old unveiling; applies revised net-debt display rule</a:t>
+              <a:t>Starts after old unveiling; validates the older supplied pipeline</a:t>
             </a:r>
           </a:p>
         </p:txBody>
@@ -3964,7 +3984,7 @@
                   <a:srgbClr val="243B53"/>
                 </a:solidFill>
               </a:rPr>
-              <a:t>New rebuild</a:t>
+              <a:t>B · Primary test</a:t>
             </a:r>
           </a:p>
         </p:txBody>
@@ -4015,7 +4035,7 @@
                   <a:srgbClr val="243B53"/>
                 </a:solidFill>
               </a:rPr>
-              <a:t>2026 public FWTW</a:t>
+              <a:t>2021 direct cells</a:t>
             </a:r>
           </a:p>
         </p:txBody>
@@ -4117,7 +4137,7 @@
                   <a:srgbClr val="243B53"/>
                 </a:solidFill>
               </a:rPr>
-              <a:t>31 instruments; 25 substantive sectors; 2021 DINA/NIPA to 2016</a:t>
+              <a:t>351 saved direct fields; eight coarsened intermediary rows; no round fields read</a:t>
             </a:r>
           </a:p>
         </p:txBody>
@@ -4199,7 +4219,7 @@
                   <a:srgbClr val="243B53"/>
                 </a:solidFill>
               </a:rPr>
-              <a:t>Household split</a:t>
+              <a:t>C · Robustness</a:t>
             </a:r>
           </a:p>
         </p:txBody>
@@ -4250,7 +4270,7 @@
                   <a:srgbClr val="243B53"/>
                 </a:solidFill>
               </a:rPr>
-              <a:t>Fine DINA shares</a:t>
+              <a:t>Public 2026 FWTW</a:t>
             </a:r>
           </a:p>
         </p:txBody>
@@ -4301,7 +4321,7 @@
                   <a:srgbClr val="2F855A"/>
                 </a:solidFill>
               </a:rPr>
-              <a:t>Before solve</a:t>
+              <a:t>Full inverse</a:t>
             </a:r>
           </a:p>
         </p:txBody>
@@ -4352,7 +4372,7 @@
                   <a:srgbClr val="243B53"/>
                 </a:solidFill>
               </a:rPr>
-              <a:t>Asset-class shares split every direct household-holder cell by wealth group</a:t>
+              <a:t>31 instruments; 25 substantive sectors; independent current taxonomy</a:t>
             </a:r>
           </a:p>
         </p:txBody>
@@ -4434,7 +4454,7 @@
                   <a:srgbClr val="243B53"/>
                 </a:solidFill>
               </a:rPr>
-              <a:t>Debt owed</a:t>
+              <a:t>Common layer</a:t>
             </a:r>
           </a:p>
         </p:txBody>
@@ -4485,7 +4505,7 @@
                   <a:srgbClr val="243B53"/>
                 </a:solidFill>
               </a:rPr>
-              <a:t>Public FWTW totals</a:t>
+              <a:t>2021 DINA/NIPA</a:t>
             </a:r>
           </a:p>
         </p:txBody>
@@ -4536,7 +4556,7 @@
                   <a:srgbClr val="C65D16"/>
                 </a:solidFill>
               </a:rPr>
-              <a:t>DINA split</a:t>
+              <a:t>Through 2016</a:t>
             </a:r>
           </a:p>
         </p:txBody>
@@ -4587,7 +4607,7 @@
                   <a:srgbClr val="243B53"/>
                 </a:solidFill>
               </a:rPr>
-              <a:t>Owner-mortgage shares + nonmortgage shares; five debt instruments</a:t>
+              <a:t>Same groups, net-debt sign, national-income scale, and 1982 base</a:t>
             </a:r>
           </a:p>
         </p:txBody>
@@ -4669,7 +4689,7 @@
                   <a:srgbClr val="243B53"/>
                 </a:solidFill>
               </a:rPr>
-              <a:t>Main test</a:t>
+              <a:t>Identification</a:t>
             </a:r>
           </a:p>
         </p:txBody>
@@ -4720,7 +4740,7 @@
                   <a:srgbClr val="243B53"/>
                 </a:solidFill>
               </a:rPr>
-              <a:t>Both vs paper</a:t>
+              <a:t>A versus B</a:t>
             </a:r>
           </a:p>
         </p:txBody>
@@ -4771,7 +4791,7 @@
                   <a:srgbClr val="627D98"/>
                 </a:solidFill>
               </a:rPr>
-              <a:t>Diagnostic</a:t>
+              <a:t>Closest operator test</a:t>
             </a:r>
           </a:p>
         </p:txBody>
@@ -4822,7 +4842,7 @@
                   <a:srgbClr val="243B53"/>
                 </a:solidFill>
               </a:rPr>
-              <a:t>Operator and vintage change together; do not read the gap as causal</a:t>
+              <a:t>Not exact: the kit does not save the full 34×27 annual direct cube</a:t>
             </a:r>
           </a:p>
         </p:txBody>
@@ -4937,7 +4957,7 @@
                   <a:srgbClr val="102A43"/>
                 </a:solidFill>
               </a:rPr>
-              <a:t>Rule</a:t>
+              <a:t>Hierarchy</a:t>
             </a:r>
           </a:p>
         </p:txBody>
@@ -4988,7 +5008,7 @@
                   <a:srgbClr val="243B53"/>
                 </a:solidFill>
               </a:rPr>
-              <a:t>Use the new route for the final replication result; keep the old route as a transparent lineage benchmark.</a:t>
+              <a:t>Lead with B; use A as the older-code benchmark and C as a public-data robustness check.</a:t>
             </a:r>
           </a:p>
         </p:txBody>
@@ -5068,7 +5088,7 @@
                   <a:srgbClr val="C65D16"/>
                 </a:solidFill>
               </a:rPr>
-              <a:t>PREFERRED IMPLEMENTATION</a:t>
+              <a:t>PRIMARY IMPLEMENTATION</a:t>
             </a:r>
           </a:p>
         </p:txBody>
@@ -5119,7 +5139,7 @@
                   <a:srgbClr val="102A43"/>
                 </a:solidFill>
               </a:rPr>
-              <a:t>The public FWTW route follows the 2025 operator</a:t>
+              <a:t>Restart upstream, then replace seven rounds with the full inverse</a:t>
             </a:r>
           </a:p>
         </p:txBody>
@@ -5303,7 +5323,7 @@
                   <a:srgbClr val="243B53"/>
                 </a:solidFill>
               </a:rPr>
-              <a:t>Who ultimately owns household debt after every intermediary chain?</a:t>
+              <a:t>Can the 2021 direct vintage support the 2025 operator without using any seven-round outputs?</a:t>
             </a:r>
           </a:p>
         </p:txBody>
@@ -5416,7 +5436,7 @@
                   <a:srgbClr val="627D98"/>
                 </a:solidFill>
               </a:rPr>
-              <a:t>1 · Expand</a:t>
+              <a:t>1 · Recover cells</a:t>
             </a:r>
           </a:p>
         </p:txBody>
@@ -5467,7 +5487,7 @@
                   <a:srgbClr val="243B53"/>
                 </a:solidFill>
               </a:rPr>
-              <a:t>Map each FWTW instrument to DINA; split the direct household holder into four wealth groups.</a:t>
+              <a:t>Read 351 pre-unveiling fields; rebuild mutual-fund allocation and eight intermediary rows.</a:t>
             </a:r>
           </a:p>
         </p:txBody>
@@ -5549,7 +5569,7 @@
                   <a:srgbClr val="2E5B88"/>
                 </a:solidFill>
               </a:rPr>
-              <a:t>2 · Unveil all chains</a:t>
+              <a:t>2 · Complete network</a:t>
             </a:r>
           </a:p>
         </p:txBody>
@@ -5600,7 +5620,7 @@
                   <a:srgbClr val="243B53"/>
                 </a:solidFill>
               </a:rPr>
-              <a:t>Sum instruments, row-normalize, then solve Ω = (I − Q)⁻¹B.</a:t>
+              <a:t>Clip signed artifacts, balance to kit margins, split households by DINA, solve Ω = (I − Q)⁻¹B.</a:t>
             </a:r>
           </a:p>
         </p:txBody>
@@ -5682,7 +5702,7 @@
                   <a:srgbClr val="C65D16"/>
                 </a:solidFill>
               </a:rPr>
-              <a:t>3 · Form net debt</a:t>
+              <a:t>3 · Net debt</a:t>
             </a:r>
           </a:p>
         </p:txBody>
@@ -5733,7 +5753,7 @@
                   <a:srgbClr val="243B53"/>
                 </a:solidFill>
               </a:rPr>
-              <a:t>Allocate household-debt assets through Omega; subtract mortgage and nonmortgage liabilities.</a:t>
+              <a:t>Trace household-debt assets to ultimate owners; subtract group mortgage and nonmortgage debt.</a:t>
             </a:r>
           </a:p>
         </p:txBody>
@@ -5817,7 +5837,7 @@
                   <a:srgbClr val="B83232"/>
                 </a:solidFill>
               </a:rPr>
-              <a:t>Invariant</a:t>
+              <a:t>Verified boundary</a:t>
             </a:r>
           </a:p>
         </p:txBody>
@@ -5868,7 +5888,7 @@
                   <a:srgbClr val="243B53"/>
                 </a:solidFill>
               </a:rPr>
-              <a:t>Every direct and unveiled row sums to one; all-owner debt assets and household-group liabilities each close to aggregate debt.</a:t>
+              <a:t>Zero seven-round variables read; source debt margins close within $2 million and unveiled ownership rows within 4.5×10⁻¹⁶.</a:t>
             </a:r>
           </a:p>
         </p:txBody>
@@ -5948,7 +5968,7 @@
                   <a:srgbClr val="C65D16"/>
                 </a:solidFill>
               </a:rPr>
-              <a:t>DATA AND TAXONOMY BOUNDARY</a:t>
+              <a:t>PUBLIC-DATA ROBUSTNESS</a:t>
             </a:r>
           </a:p>
         </p:txBody>
@@ -5999,7 +6019,7 @@
                   <a:srgbClr val="102A43"/>
                 </a:solidFill>
               </a:rPr>
-              <a:t>The method is close; the exact 2025 vintage is unavailable</a:t>
+              <a:t>Public FWTW tests portability—not a same-vintage effect</a:t>
             </a:r>
           </a:p>
         </p:txBody>
@@ -6183,7 +6203,7 @@
                   <a:srgbClr val="243B53"/>
                 </a:solidFill>
               </a:rPr>
-              <a:t>Mixed-vintage method reconstruction</a:t>
+              <a:t>Same full operator</a:t>
             </a:r>
           </a:p>
           <a:p xmlns:a="http://schemas.openxmlformats.org/drawingml/2006/main">
@@ -6201,7 +6221,7 @@
                   <a:srgbClr val="243B53"/>
                 </a:solidFill>
               </a:rPr>
-              <a:t>Not an exact numerical reproduction</a:t>
+              <a:t>Different completed direct matrix</a:t>
             </a:r>
           </a:p>
         </p:txBody>
@@ -6365,7 +6385,7 @@
                   <a:srgbClr val="243B53"/>
                 </a:solidFill>
               </a:rPr>
-              <a:t>Completed bilateral estimates: 31 instruments, 25 substantive sectors, June 2026 vintage.</a:t>
+              <a:t>June 2026 release: 31 instruments and 25 substantive sectors, already completed by the Fed.</a:t>
             </a:r>
           </a:p>
         </p:txBody>
@@ -6447,7 +6467,7 @@
                   <a:srgbClr val="2E5B88"/>
                 </a:solidFill>
               </a:rPr>
-              <a:t>2 · Distributional layer</a:t>
+              <a:t>2 · Common layer</a:t>
             </a:r>
           </a:p>
         </p:txBody>
@@ -6498,7 +6518,7 @@
                   <a:srgbClr val="243B53"/>
                 </a:solidFill>
               </a:rPr>
-              <a:t>Fine DINA asset and liability shares plus authors-kit national income, 1963–2016.</a:t>
+              <a:t>Reuse 2021 DINA group shares and authors-kit national income; stop in 2016.</a:t>
             </a:r>
           </a:p>
         </p:txBody>
@@ -6580,7 +6600,7 @@
                   <a:srgbClr val="C65D16"/>
                 </a:solidFill>
               </a:rPr>
-              <a:t>3 · Signed levels</a:t>
+              <a:t>3 · Full solve</a:t>
             </a:r>
           </a:p>
         </p:txBody>
@@ -6631,7 +6651,7 @@
                   <a:srgbClr val="243B53"/>
                 </a:solidFill>
               </a:rPr>
-              <a:t>Negative positions reverse direction per the Fed note; zero clipping is a sensitivity.</a:t>
+              <a:t>Split household holders, reorient negative positions, and apply the same Leontief operator.</a:t>
             </a:r>
           </a:p>
         </p:txBody>
@@ -6715,7 +6735,7 @@
                   <a:srgbClr val="B83232"/>
                 </a:solidFill>
               </a:rPr>
-              <a:t>Vintage gap</a:t>
+              <a:t>Interpretation</a:t>
             </a:r>
           </a:p>
         </p:txBody>
@@ -6766,7 +6786,7 @@
                   <a:srgbClr val="243B53"/>
                 </a:solidFill>
               </a:rPr>
-              <a:t>The paper’s 34-instrument, 27-sector matrices, exact crosswalk, and through-2019 extension were not recovered.</a:t>
+              <a:t>Useful robustness, but operator, vintage, taxonomy, completion algorithm, and corporate-equity coverage differ from the paper.</a:t>
             </a:r>
           </a:p>
         </p:txBody>
@@ -6897,7 +6917,7 @@
                   <a:srgbClr val="102A43"/>
                 </a:solidFill>
               </a:rPr>
-              <a:t>Full unveiling improves top-1 fit, not every level</a:t>
+              <a:t>All routes recover the split; level gaps remain</a:t>
             </a:r>
           </a:p>
         </p:txBody>
@@ -7030,7 +7050,7 @@
                   <a:srgbClr val="2E5B88"/>
                 </a:solidFill>
               </a:rPr>
-              <a:t>Top 1% · 2025 paper vs both implementations</a:t>
+              <a:t>Top 1% · paper plus three routes</a:t>
             </a:r>
           </a:p>
         </p:txBody>
@@ -7081,7 +7101,7 @@
                   <a:srgbClr val="C65D16"/>
                 </a:solidFill>
               </a:rPr>
-              <a:t>Bottom 99% · 2025 paper vs both implementations</a:t>
+              <a:t>Bottom 99% · paper plus three routes</a:t>
             </a:r>
           </a:p>
         </p:txBody>
@@ -7266,7 +7286,7 @@
                   <a:srgbClr val="2F855A"/>
                 </a:solidFill>
               </a:rPr>
-              <a:t>MIXED IMPROVEMENT</a:t>
+              <a:t>TREND ROBUST</a:t>
             </a:r>
           </a:p>
         </p:txBody>
@@ -7317,7 +7337,7 @@
                   <a:srgbClr val="243B53"/>
                 </a:solidFill>
               </a:rPr>
-              <a:t>Top-1 MAE: 2.12 pp new vs 2.41 proxy. Bottom-99 MAE: 1.98 pp new vs 1.38 proxy.</a:t>
+              <a:t>Top-1 MAE: 2.33 pp for 2021-direct/full vs 2.41 proxy; public/full is 2.12 pp.</a:t>
             </a:r>
           </a:p>
         </p:txBody>
@@ -7368,7 +7388,7 @@
                   <a:srgbClr val="627D98"/>
                 </a:solidFill>
               </a:rPr>
-              <a:t>Top-1 correlation rises to 0.998. The 2007 new result is +12.28 / −44.31 pp versus paper +18.02 / −38.76 pp.</a:t>
+              <a:t>Bottom-99 MAE: 1.31 pp for 2021-direct/full vs 1.38 proxy; public/full is 1.98 pp.</a:t>
             </a:r>
           </a:p>
         </p:txBody>
@@ -7382,7 +7402,7 @@
           <p:nvPr/>
         </p:nvPicPr>
         <p:blipFill>
-          <a:blip xmlns:r="http://schemas.openxmlformats.org/officeDocument/2006/relationships" xmlns:a="http://schemas.openxmlformats.org/drawingml/2006/main" r:embed="R06a0b480ed4f438e"/>
+          <a:blip xmlns:r="http://schemas.openxmlformats.org/officeDocument/2006/relationships" xmlns:a="http://schemas.openxmlformats.org/drawingml/2006/main" r:embed="Re01f842d57d14f4d"/>
           <a:stretch xmlns:a="http://schemas.openxmlformats.org/drawingml/2006/main"/>
         </p:blipFill>
         <p:spPr>
@@ -7404,7 +7424,7 @@
           <p:nvPr/>
         </p:nvPicPr>
         <p:blipFill>
-          <a:blip xmlns:r="http://schemas.openxmlformats.org/officeDocument/2006/relationships" xmlns:a="http://schemas.openxmlformats.org/drawingml/2006/main" r:embed="R0bc73c2b587749df"/>
+          <a:blip xmlns:r="http://schemas.openxmlformats.org/officeDocument/2006/relationships" xmlns:a="http://schemas.openxmlformats.org/drawingml/2006/main" r:embed="R99fe566bdaee4e4d"/>
           <a:stretch xmlns:a="http://schemas.openxmlformats.org/drawingml/2006/main"/>
         </p:blipFill>
         <p:spPr>
@@ -7492,7 +7512,7 @@
                   <a:srgbClr val="C65D16"/>
                 </a:solidFill>
               </a:rPr>
-              <a:t>VALIDATION AND SENSITIVITY</a:t>
+              <a:t>SAME-VINTAGE OPERATOR TEST</a:t>
             </a:r>
           </a:p>
         </p:txBody>
@@ -7543,7 +7563,7 @@
                   <a:srgbClr val="102A43"/>
                 </a:solidFill>
               </a:rPr>
-              <a:t>The preferred result is stable to negative-cell treatment</a:t>
+              <a:t>The full inverse changes the old network only modestly</a:t>
             </a:r>
           </a:p>
         </p:txBody>
@@ -7676,7 +7696,7 @@
                   <a:srgbClr val="2E5B88"/>
                 </a:solidFill>
               </a:rPr>
-              <a:t>Preferred reconstruction · five wealth groups</a:t>
+              <a:t>B minus A · full inverse minus seven rounds</a:t>
             </a:r>
           </a:p>
         </p:txBody>
@@ -7727,7 +7747,7 @@
                   <a:srgbClr val="C65D16"/>
                 </a:solidFill>
               </a:rPr>
-              <a:t>Reorient negative positions vs clip to zero</a:t>
+              <a:t>B · 2021 direct cells + full inverse</a:t>
             </a:r>
           </a:p>
         </p:txBody>
@@ -7912,7 +7932,7 @@
                   <a:srgbClr val="2F855A"/>
                 </a:solidFill>
               </a:rPr>
-              <a:t>ACCOUNTING CLOSES</a:t>
+              <a:t>TRUNCATION IS NOT THE MAIN GAP</a:t>
             </a:r>
           </a:p>
         </p:txBody>
@@ -7963,7 +7983,7 @@
                   <a:srgbClr val="243B53"/>
                 </a:solidFill>
               </a:rPr>
-              <a:t>Max spectral radius 0.504; direct, unveiled, and primary-asset closure errors below 9×10⁻¹⁶.</a:t>
+              <a:t>Mean |B−A|: 0.26 pp top 1% and 0.75 pp bottom 99%; 2007 differences are −0.56 and −2.15 pp.</a:t>
             </a:r>
           </a:p>
         </p:txBody>
@@ -8014,7 +8034,7 @@
                   <a:srgbClr val="627D98"/>
                 </a:solidFill>
               </a:rPr>
-              <a:t>Reorientation vs clipping changes top 1% by at most 0.09 pp and bottom 99% by at most 0.17 pp.</a:t>
+              <a:t>Caveat: signed-cell clipping absorbs 8.5–37.8% of gross debt-cell mass; 3.2–10.0% remains unassigned after coarsening.</a:t>
             </a:r>
           </a:p>
         </p:txBody>
@@ -8028,7 +8048,7 @@
           <p:nvPr/>
         </p:nvPicPr>
         <p:blipFill>
-          <a:blip xmlns:r="http://schemas.openxmlformats.org/officeDocument/2006/relationships" xmlns:a="http://schemas.openxmlformats.org/drawingml/2006/main" r:embed="R254c2310974a4f6c"/>
+          <a:blip xmlns:r="http://schemas.openxmlformats.org/officeDocument/2006/relationships" xmlns:a="http://schemas.openxmlformats.org/drawingml/2006/main" r:embed="Rf1110c8e16664e61"/>
           <a:stretch xmlns:a="http://schemas.openxmlformats.org/drawingml/2006/main"/>
         </p:blipFill>
         <p:spPr>
@@ -8050,7 +8070,7 @@
           <p:nvPr/>
         </p:nvPicPr>
         <p:blipFill>
-          <a:blip xmlns:r="http://schemas.openxmlformats.org/officeDocument/2006/relationships" xmlns:a="http://schemas.openxmlformats.org/drawingml/2006/main" r:embed="Rbf98e4755b294c00"/>
+          <a:blip xmlns:r="http://schemas.openxmlformats.org/officeDocument/2006/relationships" xmlns:a="http://schemas.openxmlformats.org/drawingml/2006/main" r:embed="R59cb072834964e28"/>
           <a:stretch xmlns:a="http://schemas.openxmlformats.org/drawingml/2006/main"/>
         </p:blipFill>
         <p:spPr>
@@ -8189,7 +8209,7 @@
                   <a:srgbClr val="102A43"/>
                 </a:solidFill>
               </a:rPr>
-              <a:t>Use the full-Leontief result; retain the proxy as lineage</a:t>
+              <a:t>Lead with the same-vintage test; keep both comparators</a:t>
             </a:r>
           </a:p>
         </p:txBody>
@@ -8373,7 +8393,25 @@
                   <a:srgbClr val="243B53"/>
                 </a:solidFill>
               </a:rPr>
-              <a:t>Lead with the new method reconstruction; show the old proxy as an audit.</a:t>
+              <a:t>Primary: 2021 direct cells + full inverse.</a:t>
+            </a:r>
+          </a:p>
+          <a:p xmlns:a="http://schemas.openxmlformats.org/drawingml/2006/main">
+            <a:pPr algn="l">
+              <a:buNone/>
+              <a:defRPr sz="1875" b="0">
+                <a:solidFill>
+                  <a:srgbClr val="243B53"/>
+                </a:solidFill>
+              </a:defRPr>
+            </a:pPr>
+            <a:r>
+              <a:rPr sz="1875" b="0">
+                <a:solidFill>
+                  <a:srgbClr val="243B53"/>
+                </a:solidFill>
+              </a:rPr>
+              <a:t>Benchmarks: old final file and public FWTW.</a:t>
             </a:r>
           </a:p>
         </p:txBody>
@@ -8486,7 +8524,7 @@
                   <a:srgbClr val="C65D16"/>
                 </a:solidFill>
               </a:rPr>
-              <a:t>Preferred result</a:t>
+              <a:t>Main result</a:t>
             </a:r>
           </a:p>
         </p:txBody>
@@ -8537,7 +8575,7 @@
                   <a:srgbClr val="243B53"/>
                 </a:solidFill>
               </a:rPr>
-              <a:t>Public completed FWTW + DINA/NIPA + full 2025 Leontief operator, 1963–2016.</a:t>
+              <a:t>Route B restarts before unveiling and applies the 2025 operator to the old data vintage through 2016.</a:t>
             </a:r>
           </a:p>
         </p:txBody>
@@ -8619,7 +8657,7 @@
                   <a:srgbClr val="627D98"/>
                 </a:solidFill>
               </a:rPr>
-              <a:t>Supporting result</a:t>
+              <a:t>Two distinct checks</a:t>
             </a:r>
           </a:p>
         </p:txBody>
@@ -8670,7 +8708,7 @@
                   <a:srgbClr val="243B53"/>
                 </a:solidFill>
               </a:rPr>
-              <a:t>2021-kit seven-round proxy preserves the older authors’ pipeline and downstream benchmark.</a:t>
+              <a:t>Route A validates the supplied older pipeline; Route C tests the method on current public bilateral data.</a:t>
             </a:r>
           </a:p>
         </p:txBody>
@@ -8752,7 +8790,7 @@
                   <a:srgbClr val="2E5B88"/>
                 </a:solidFill>
               </a:rPr>
-              <a:t>Interpretation</a:t>
+              <a:t>Economic conclusion</a:t>
             </a:r>
           </a:p>
         </p:txBody>
@@ -8803,7 +8841,7 @@
                   <a:srgbClr val="243B53"/>
                 </a:solidFill>
               </a:rPr>
-              <a:t>Both reproduce the central split: rising top-1 lending and bottom-99 borrowing after 1982.</a:t>
+              <a:t>All three show rising top-1 net lending and increasingly negative bottom-99 net debt after 1982.</a:t>
             </a:r>
           </a:p>
         </p:txBody>
@@ -8938,7 +8976,7 @@
                   <a:srgbClr val="243B53"/>
                 </a:solidFill>
               </a:rPr>
-              <a:t>Operator, public vintage, taxonomy, and sample endpoint change together; the remaining paper gap is not a pure code effect.</a:t>
+              <a:t>The small A→B gap suggests seven-round truncation is not the main paper discrepancy; matrix coverage, completion, taxonomy, and wealth mapping remain.</a:t>
             </a:r>
           </a:p>
         </p:txBody>

</xml_diff>